<commit_message>
Add bottom-line statement to the narrative title slide
Closes the title slide with the value promise, set off by a blue accent bar, and demotes the repo URL to a footer line beneath it so the statement carries the closing weight.

Co-authored-by: Copilot App <223556219+Copilot@users.noreply.github.com>
</commit_message>
<xml_diff>
--- a/docs/assets/Fabric-Demo-Generator-Narrative.pptx
+++ b/docs/assets/Fabric-Demo-Generator-Narrative.pptx
@@ -3255,11 +3255,110 @@
               <a:t>Retail · Manufacturing · FSI · Healthcare · Life Science</a:t>
             </a:r>
           </a:p>
-          <a:p>
-            <a:pPr>
-              <a:spcBef>
-                <a:spcPts val="2000"/>
-              </a:spcBef>
+        </p:txBody>
+      </p:sp>
+      <p:sp>
+        <p:nvSpPr>
+          <p:cNvPr id="6" name="Rectangle 5"/>
+          <p:cNvSpPr/>
+          <p:nvPr/>
+        </p:nvSpPr>
+        <p:spPr>
+          <a:xfrm>
+            <a:off x="914400" y="5074920"/>
+            <a:ext cx="82296" cy="548640"/>
+          </a:xfrm>
+          <a:prstGeom prst="rect">
+            <a:avLst/>
+          </a:prstGeom>
+          <a:solidFill>
+            <a:srgbClr val="0078D4"/>
+          </a:solidFill>
+          <a:ln>
+            <a:noFill/>
+          </a:ln>
+        </p:spPr>
+        <p:style>
+          <a:lnRef idx="1">
+            <a:schemeClr val="accent1"/>
+          </a:lnRef>
+          <a:fillRef idx="3">
+            <a:schemeClr val="accent1"/>
+          </a:fillRef>
+          <a:effectRef idx="2">
+            <a:schemeClr val="accent1"/>
+          </a:effectRef>
+          <a:fontRef idx="minor">
+            <a:schemeClr val="lt1"/>
+          </a:fontRef>
+        </p:style>
+        <p:txBody>
+          <a:bodyPr rtlCol="0" anchor="ctr"/>
+          <a:lstStyle/>
+          <a:p>
+            <a:pPr algn="ctr"/>
+          </a:p>
+        </p:txBody>
+      </p:sp>
+      <p:sp>
+        <p:nvSpPr>
+          <p:cNvPr id="7" name="TextBox 6"/>
+          <p:cNvSpPr txBox="1"/>
+          <p:nvPr/>
+        </p:nvSpPr>
+        <p:spPr>
+          <a:xfrm>
+            <a:off x="1170432" y="5102352"/>
+            <a:ext cx="10058400" cy="548640"/>
+          </a:xfrm>
+          <a:prstGeom prst="rect">
+            <a:avLst/>
+          </a:prstGeom>
+          <a:noFill/>
+        </p:spPr>
+        <p:txBody>
+          <a:bodyPr wrap="square">
+            <a:spAutoFit/>
+          </a:bodyPr>
+          <a:lstStyle/>
+          <a:p>
+            <a:pPr algn="l">
+              <a:defRPr sz="2200" b="1">
+                <a:solidFill>
+                  <a:srgbClr val="FFFFFF"/>
+                </a:solidFill>
+                <a:latin typeface="Segoe UI"/>
+              </a:defRPr>
+            </a:pPr>
+            <a:r>
+              <a:t>From empty workspace to data-agent-ready model in five minutes.</a:t>
+            </a:r>
+          </a:p>
+        </p:txBody>
+      </p:sp>
+      <p:sp>
+        <p:nvSpPr>
+          <p:cNvPr id="8" name="TextBox 7"/>
+          <p:cNvSpPr txBox="1"/>
+          <p:nvPr/>
+        </p:nvSpPr>
+        <p:spPr>
+          <a:xfrm>
+            <a:off x="914400" y="5943600"/>
+            <a:ext cx="10058400" cy="365760"/>
+          </a:xfrm>
+          <a:prstGeom prst="rect">
+            <a:avLst/>
+          </a:prstGeom>
+          <a:noFill/>
+        </p:spPr>
+        <p:txBody>
+          <a:bodyPr wrap="square">
+            <a:spAutoFit/>
+          </a:bodyPr>
+          <a:lstStyle/>
+          <a:p>
+            <a:pPr algn="l">
               <a:defRPr sz="1400" b="0">
                 <a:solidFill>
                   <a:srgbClr val="0078D4"/>

</xml_diff>